<commit_message>
Refactor codebase: simplify documentation, clean up code comments, and update validation report filenames
</commit_message>
<xml_diff>
--- a/reports/Presentation.pptx
+++ b/reports/Presentation.pptx
@@ -3208,7 +3208,7 @@
               </a:defRPr>
             </a:pPr>
             <a:r>
-              <a:t>Company: Bluestock Fintech Pvt. Ltd. (Capstone Project)</a:t>
+              <a:t>Mutual Fund Performance Analytics</a:t>
             </a:r>
           </a:p>
           <a:p>
@@ -3224,7 +3224,7 @@
               </a:defRPr>
             </a:pPr>
             <a:r>
-              <a:t>Prepared By: Srujan / Data Analyst Intern</a:t>
+              <a:t>Prepared By: Srujan / Quantitative Analyst</a:t>
             </a:r>
           </a:p>
           <a:p>
@@ -5054,7 +5054,7 @@
               </a:defRPr>
             </a:pPr>
             <a:r>
-              <a:t>Capstone Project Objectives</a:t>
+              <a:t>Analytics Project Objectives</a:t>
             </a:r>
           </a:p>
         </p:txBody>
@@ -5093,7 +5093,7 @@
               </a:defRPr>
             </a:pPr>
             <a:r>
-              <a:t>Key Deliverables &amp; Outcomes achieved during the 7-Day Timeline:</a:t>
+              <a:t>Key Deliverables &amp; Outcomes achieved during the Project Timeline:</a:t>
             </a:r>
           </a:p>
           <a:p>
@@ -5109,7 +5109,7 @@
               </a:defRPr>
             </a:pPr>
             <a:r>
-              <a:t>Day 1-2: Automated Ingestion &amp; SQL Database Design</a:t>
+              <a:t>Phase 1: Automated Ingestion &amp; SQL Database Design</a:t>
             </a:r>
           </a:p>
           <a:p>
@@ -5157,7 +5157,7 @@
               </a:defRPr>
             </a:pPr>
             <a:r>
-              <a:t>Day 3-4: Exploratory Data Analysis &amp; Performance Scoring</a:t>
+              <a:t>Phase 2: Exploratory Data Analysis &amp; Performance Scoring</a:t>
             </a:r>
           </a:p>
           <a:p>
@@ -5205,7 +5205,7 @@
               </a:defRPr>
             </a:pPr>
             <a:r>
-              <a:t>Day 5-7: Interactive Visualization, Advanced Analytics &amp; Delivery</a:t>
+              <a:t>Phase 3: Interactive Visualization, Advanced Analytics &amp; Delivery</a:t>
             </a:r>
           </a:p>
           <a:p>

</xml_diff>